<commit_message>
Fix corrupt pptx: rebuild package without zip directory entries
The previous archive contained directory entries and was fully
recompressed via shell zip, which PowerPoint's OPC reader rejects as
unreadable. Rebuild programmatically: [Content_Types].xml first, no
directory entries, original parts preserved, only edited manifests and
the 5 new package slides changed.

Co-Authored-By: Claude Opus 4.8 <noreply@anthropic.com>
Claude-Session: https://claude.ai/code/session_016aCZqJCZT6xQTnHn6zqHR8
</commit_message>
<xml_diff>
--- a/AsiaGo_Pass_Presentation1_enhanced.pptx
+++ b/AsiaGo_Pass_Presentation1_enhanced.pptx
@@ -15224,7 +15224,7 @@
       </p:grpSpPr>
       <p:sp>
         <p:nvSpPr>
-          <p:cNvPr id="11" name="hero"/>
+          <p:cNvPr id="11" name="r"/>
           <p:cNvSpPr/>
           <p:nvPr/>
         </p:nvSpPr>
@@ -15250,7 +15250,6 @@
             </a:gsLst>
             <a:lin ang="2700000" scaled="1"/>
           </a:gradFill>
-          <a:ln/>
         </p:spPr>
         <p:txBody>
           <a:bodyPr/>
@@ -15275,7 +15274,6 @@
             <a:avLst/>
           </a:prstGeom>
           <a:noFill/>
-          <a:ln/>
         </p:spPr>
         <p:txBody>
           <a:bodyPr wrap="square" lIns="0" tIns="0" rIns="0" bIns="0" rtlCol="0" anchor="t"/>
@@ -15312,7 +15310,6 @@
             <a:avLst/>
           </a:prstGeom>
           <a:noFill/>
-          <a:ln/>
         </p:spPr>
         <p:txBody>
           <a:bodyPr wrap="square" lIns="0" tIns="0" rIns="0" bIns="0" rtlCol="0" anchor="t"/>
@@ -15352,7 +15349,6 @@
             <a:avLst/>
           </a:prstGeom>
           <a:noFill/>
-          <a:ln/>
         </p:spPr>
         <p:txBody>
           <a:bodyPr wrap="square" lIns="0" tIns="0" rIns="0" bIns="0" rtlCol="0" anchor="t"/>
@@ -15643,7 +15639,7 @@
       </p:sp>
       <p:sp>
         <p:nvSpPr>
-          <p:cNvPr id="18" name="strip"/>
+          <p:cNvPr id="18" name="r"/>
           <p:cNvSpPr/>
           <p:nvPr/>
         </p:nvSpPr>
@@ -15658,7 +15654,6 @@
           <a:solidFill>
             <a:srgbClr val="BA7517"/>
           </a:solidFill>
-          <a:ln/>
         </p:spPr>
         <p:txBody>
           <a:bodyPr/>
@@ -15683,7 +15678,6 @@
             <a:avLst/>
           </a:prstGeom>
           <a:noFill/>
-          <a:ln/>
         </p:spPr>
         <p:txBody>
           <a:bodyPr wrap="square" lIns="0" tIns="0" rIns="0" bIns="0" rtlCol="0" anchor="t"/>
@@ -15707,7 +15701,7 @@
       </p:sp>
       <p:sp>
         <p:nvSpPr>
-          <p:cNvPr id="20" name="strip"/>
+          <p:cNvPr id="20" name="r"/>
           <p:cNvSpPr/>
           <p:nvPr/>
         </p:nvSpPr>
@@ -15722,7 +15716,6 @@
           <a:solidFill>
             <a:srgbClr val="BA7517"/>
           </a:solidFill>
-          <a:ln/>
         </p:spPr>
         <p:txBody>
           <a:bodyPr/>
@@ -15747,7 +15740,6 @@
             <a:avLst/>
           </a:prstGeom>
           <a:noFill/>
-          <a:ln/>
         </p:spPr>
         <p:txBody>
           <a:bodyPr wrap="square" lIns="0" tIns="0" rIns="0" bIns="0" rtlCol="0" anchor="t"/>
@@ -15784,7 +15776,6 @@
             <a:avLst/>
           </a:prstGeom>
           <a:noFill/>
-          <a:ln/>
         </p:spPr>
         <p:txBody>
           <a:bodyPr wrap="square" lIns="0" tIns="0" rIns="0" bIns="0" rtlCol="0" anchor="t"/>
@@ -15981,7 +15972,6 @@
             <a:avLst/>
           </a:prstGeom>
           <a:noFill/>
-          <a:ln/>
         </p:spPr>
         <p:txBody>
           <a:bodyPr wrap="square" lIns="0" tIns="0" rIns="0" bIns="0" rtlCol="0" anchor="t"/>
@@ -16210,7 +16200,6 @@
             <a:avLst/>
           </a:prstGeom>
           <a:noFill/>
-          <a:ln/>
         </p:spPr>
         <p:txBody>
           <a:bodyPr wrap="square" lIns="0" tIns="0" rIns="0" bIns="0" rtlCol="0" anchor="t"/>
@@ -16247,7 +16236,6 @@
             <a:avLst/>
           </a:prstGeom>
           <a:noFill/>
-          <a:ln/>
         </p:spPr>
         <p:txBody>
           <a:bodyPr wrap="square" lIns="0" tIns="0" rIns="0" bIns="0" rtlCol="0" anchor="t"/>
@@ -16304,7 +16292,7 @@
       </p:grpSpPr>
       <p:sp>
         <p:nvSpPr>
-          <p:cNvPr id="11" name="hero"/>
+          <p:cNvPr id="11" name="r"/>
           <p:cNvSpPr/>
           <p:nvPr/>
         </p:nvSpPr>
@@ -16330,7 +16318,6 @@
             </a:gsLst>
             <a:lin ang="2700000" scaled="1"/>
           </a:gradFill>
-          <a:ln/>
         </p:spPr>
         <p:txBody>
           <a:bodyPr/>
@@ -16355,7 +16342,6 @@
             <a:avLst/>
           </a:prstGeom>
           <a:noFill/>
-          <a:ln/>
         </p:spPr>
         <p:txBody>
           <a:bodyPr wrap="square" lIns="0" tIns="0" rIns="0" bIns="0" rtlCol="0" anchor="t"/>
@@ -16392,7 +16378,6 @@
             <a:avLst/>
           </a:prstGeom>
           <a:noFill/>
-          <a:ln/>
         </p:spPr>
         <p:txBody>
           <a:bodyPr wrap="square" lIns="0" tIns="0" rIns="0" bIns="0" rtlCol="0" anchor="t"/>
@@ -16432,7 +16417,6 @@
             <a:avLst/>
           </a:prstGeom>
           <a:noFill/>
-          <a:ln/>
         </p:spPr>
         <p:txBody>
           <a:bodyPr wrap="square" lIns="0" tIns="0" rIns="0" bIns="0" rtlCol="0" anchor="t"/>
@@ -16723,7 +16707,7 @@
       </p:sp>
       <p:sp>
         <p:nvSpPr>
-          <p:cNvPr id="18" name="strip"/>
+          <p:cNvPr id="18" name="r"/>
           <p:cNvSpPr/>
           <p:nvPr/>
         </p:nvSpPr>
@@ -16738,7 +16722,6 @@
           <a:solidFill>
             <a:srgbClr val="185FA5"/>
           </a:solidFill>
-          <a:ln/>
         </p:spPr>
         <p:txBody>
           <a:bodyPr/>
@@ -16763,7 +16746,6 @@
             <a:avLst/>
           </a:prstGeom>
           <a:noFill/>
-          <a:ln/>
         </p:spPr>
         <p:txBody>
           <a:bodyPr wrap="square" lIns="0" tIns="0" rIns="0" bIns="0" rtlCol="0" anchor="t"/>
@@ -16787,7 +16769,7 @@
       </p:sp>
       <p:sp>
         <p:nvSpPr>
-          <p:cNvPr id="20" name="strip"/>
+          <p:cNvPr id="20" name="r"/>
           <p:cNvSpPr/>
           <p:nvPr/>
         </p:nvSpPr>
@@ -16802,7 +16784,6 @@
           <a:solidFill>
             <a:srgbClr val="185FA5"/>
           </a:solidFill>
-          <a:ln/>
         </p:spPr>
         <p:txBody>
           <a:bodyPr/>
@@ -16827,7 +16808,6 @@
             <a:avLst/>
           </a:prstGeom>
           <a:noFill/>
-          <a:ln/>
         </p:spPr>
         <p:txBody>
           <a:bodyPr wrap="square" lIns="0" tIns="0" rIns="0" bIns="0" rtlCol="0" anchor="t"/>
@@ -16864,7 +16844,6 @@
             <a:avLst/>
           </a:prstGeom>
           <a:noFill/>
-          <a:ln/>
         </p:spPr>
         <p:txBody>
           <a:bodyPr wrap="square" lIns="0" tIns="0" rIns="0" bIns="0" rtlCol="0" anchor="t"/>
@@ -17041,7 +17020,7 @@
                 <a:latin typeface="Calibri" pitchFamily="34" charset="0"/>
                 <a:cs typeface="Calibri" pitchFamily="34" charset="0"/>
               </a:rPr>
-              <a:t>Night Safari entrance + 40-min tram ride (7 zones, 900+ animals)</a:t>
+              <a:t>Night Safari + 40-min tram ride (7 zones, 900+ animals)</a:t>
             </a:r>
           </a:p>
           <a:p>
@@ -17086,7 +17065,6 @@
             <a:avLst/>
           </a:prstGeom>
           <a:noFill/>
-          <a:ln/>
         </p:spPr>
         <p:txBody>
           <a:bodyPr wrap="square" lIns="0" tIns="0" rIns="0" bIns="0" rtlCol="0" anchor="t"/>
@@ -17315,7 +17293,6 @@
             <a:avLst/>
           </a:prstGeom>
           <a:noFill/>
-          <a:ln/>
         </p:spPr>
         <p:txBody>
           <a:bodyPr wrap="square" lIns="0" tIns="0" rIns="0" bIns="0" rtlCol="0" anchor="t"/>
@@ -17352,7 +17329,6 @@
             <a:avLst/>
           </a:prstGeom>
           <a:noFill/>
-          <a:ln/>
         </p:spPr>
         <p:txBody>
           <a:bodyPr wrap="square" lIns="0" tIns="0" rIns="0" bIns="0" rtlCol="0" anchor="t"/>
@@ -17389,7 +17365,6 @@
             <a:avLst/>
           </a:prstGeom>
           <a:noFill/>
-          <a:ln/>
         </p:spPr>
         <p:txBody>
           <a:bodyPr wrap="square" lIns="0" tIns="0" rIns="0" bIns="0" rtlCol="0" anchor="t"/>
@@ -17449,7 +17424,7 @@
       </p:grpSpPr>
       <p:sp>
         <p:nvSpPr>
-          <p:cNvPr id="11" name="hero"/>
+          <p:cNvPr id="11" name="r"/>
           <p:cNvSpPr/>
           <p:nvPr/>
         </p:nvSpPr>
@@ -17475,7 +17450,6 @@
             </a:gsLst>
             <a:lin ang="2700000" scaled="1"/>
           </a:gradFill>
-          <a:ln/>
         </p:spPr>
         <p:txBody>
           <a:bodyPr/>
@@ -17500,7 +17474,6 @@
             <a:avLst/>
           </a:prstGeom>
           <a:noFill/>
-          <a:ln/>
         </p:spPr>
         <p:txBody>
           <a:bodyPr wrap="square" lIns="0" tIns="0" rIns="0" bIns="0" rtlCol="0" anchor="t"/>
@@ -17537,7 +17510,6 @@
             <a:avLst/>
           </a:prstGeom>
           <a:noFill/>
-          <a:ln/>
         </p:spPr>
         <p:txBody>
           <a:bodyPr wrap="square" lIns="0" tIns="0" rIns="0" bIns="0" rtlCol="0" anchor="t"/>
@@ -17577,7 +17549,6 @@
             <a:avLst/>
           </a:prstGeom>
           <a:noFill/>
-          <a:ln/>
         </p:spPr>
         <p:txBody>
           <a:bodyPr wrap="square" lIns="0" tIns="0" rIns="0" bIns="0" rtlCol="0" anchor="t"/>
@@ -17868,7 +17839,7 @@
       </p:sp>
       <p:sp>
         <p:nvSpPr>
-          <p:cNvPr id="18" name="strip"/>
+          <p:cNvPr id="18" name="r"/>
           <p:cNvSpPr/>
           <p:nvPr/>
         </p:nvSpPr>
@@ -17883,7 +17854,6 @@
           <a:solidFill>
             <a:srgbClr val="534AB7"/>
           </a:solidFill>
-          <a:ln/>
         </p:spPr>
         <p:txBody>
           <a:bodyPr/>
@@ -17908,7 +17878,6 @@
             <a:avLst/>
           </a:prstGeom>
           <a:noFill/>
-          <a:ln/>
         </p:spPr>
         <p:txBody>
           <a:bodyPr wrap="square" lIns="0" tIns="0" rIns="0" bIns="0" rtlCol="0" anchor="t"/>
@@ -17932,7 +17901,7 @@
       </p:sp>
       <p:sp>
         <p:nvSpPr>
-          <p:cNvPr id="20" name="strip"/>
+          <p:cNvPr id="20" name="r"/>
           <p:cNvSpPr/>
           <p:nvPr/>
         </p:nvSpPr>
@@ -17947,7 +17916,6 @@
           <a:solidFill>
             <a:srgbClr val="534AB7"/>
           </a:solidFill>
-          <a:ln/>
         </p:spPr>
         <p:txBody>
           <a:bodyPr/>
@@ -17972,7 +17940,6 @@
             <a:avLst/>
           </a:prstGeom>
           <a:noFill/>
-          <a:ln/>
         </p:spPr>
         <p:txBody>
           <a:bodyPr wrap="square" lIns="0" tIns="0" rIns="0" bIns="0" rtlCol="0" anchor="t"/>
@@ -18009,7 +17976,6 @@
             <a:avLst/>
           </a:prstGeom>
           <a:noFill/>
-          <a:ln/>
         </p:spPr>
         <p:txBody>
           <a:bodyPr wrap="square" lIns="0" tIns="0" rIns="0" bIns="0" rtlCol="0" anchor="t"/>
@@ -18231,7 +18197,6 @@
             <a:avLst/>
           </a:prstGeom>
           <a:noFill/>
-          <a:ln/>
         </p:spPr>
         <p:txBody>
           <a:bodyPr wrap="square" lIns="0" tIns="0" rIns="0" bIns="0" rtlCol="0" anchor="t"/>
@@ -18460,7 +18425,6 @@
             <a:avLst/>
           </a:prstGeom>
           <a:noFill/>
-          <a:ln/>
         </p:spPr>
         <p:txBody>
           <a:bodyPr wrap="square" lIns="0" tIns="0" rIns="0" bIns="0" rtlCol="0" anchor="t"/>
@@ -18497,7 +18461,6 @@
             <a:avLst/>
           </a:prstGeom>
           <a:noFill/>
-          <a:ln/>
         </p:spPr>
         <p:txBody>
           <a:bodyPr wrap="square" lIns="0" tIns="0" rIns="0" bIns="0" rtlCol="0" anchor="t"/>
@@ -18554,7 +18517,7 @@
       </p:grpSpPr>
       <p:sp>
         <p:nvSpPr>
-          <p:cNvPr id="11" name="hero"/>
+          <p:cNvPr id="11" name="r"/>
           <p:cNvSpPr/>
           <p:nvPr/>
         </p:nvSpPr>
@@ -18580,7 +18543,6 @@
             </a:gsLst>
             <a:lin ang="2700000" scaled="1"/>
           </a:gradFill>
-          <a:ln/>
         </p:spPr>
         <p:txBody>
           <a:bodyPr/>
@@ -18605,7 +18567,6 @@
             <a:avLst/>
           </a:prstGeom>
           <a:noFill/>
-          <a:ln/>
         </p:spPr>
         <p:txBody>
           <a:bodyPr wrap="square" lIns="0" tIns="0" rIns="0" bIns="0" rtlCol="0" anchor="t"/>
@@ -18642,7 +18603,6 @@
             <a:avLst/>
           </a:prstGeom>
           <a:noFill/>
-          <a:ln/>
         </p:spPr>
         <p:txBody>
           <a:bodyPr wrap="square" lIns="0" tIns="0" rIns="0" bIns="0" rtlCol="0" anchor="t"/>
@@ -18682,7 +18642,6 @@
             <a:avLst/>
           </a:prstGeom>
           <a:noFill/>
-          <a:ln/>
         </p:spPr>
         <p:txBody>
           <a:bodyPr wrap="square" lIns="0" tIns="0" rIns="0" bIns="0" rtlCol="0" anchor="t"/>
@@ -18973,7 +18932,7 @@
       </p:sp>
       <p:sp>
         <p:nvSpPr>
-          <p:cNvPr id="18" name="strip"/>
+          <p:cNvPr id="18" name="r"/>
           <p:cNvSpPr/>
           <p:nvPr/>
         </p:nvSpPr>
@@ -18988,7 +18947,6 @@
           <a:solidFill>
             <a:srgbClr val="185FA5"/>
           </a:solidFill>
-          <a:ln/>
         </p:spPr>
         <p:txBody>
           <a:bodyPr/>
@@ -19013,7 +18971,6 @@
             <a:avLst/>
           </a:prstGeom>
           <a:noFill/>
-          <a:ln/>
         </p:spPr>
         <p:txBody>
           <a:bodyPr wrap="square" lIns="0" tIns="0" rIns="0" bIns="0" rtlCol="0" anchor="t"/>
@@ -19037,7 +18994,7 @@
       </p:sp>
       <p:sp>
         <p:nvSpPr>
-          <p:cNvPr id="20" name="strip"/>
+          <p:cNvPr id="20" name="r"/>
           <p:cNvSpPr/>
           <p:nvPr/>
         </p:nvSpPr>
@@ -19052,7 +19009,6 @@
           <a:solidFill>
             <a:srgbClr val="185FA5"/>
           </a:solidFill>
-          <a:ln/>
         </p:spPr>
         <p:txBody>
           <a:bodyPr/>
@@ -19077,7 +19033,6 @@
             <a:avLst/>
           </a:prstGeom>
           <a:noFill/>
-          <a:ln/>
         </p:spPr>
         <p:txBody>
           <a:bodyPr wrap="square" lIns="0" tIns="0" rIns="0" bIns="0" rtlCol="0" anchor="t"/>
@@ -19114,7 +19069,6 @@
             <a:avLst/>
           </a:prstGeom>
           <a:noFill/>
-          <a:ln/>
         </p:spPr>
         <p:txBody>
           <a:bodyPr wrap="square" lIns="0" tIns="0" rIns="0" bIns="0" rtlCol="0" anchor="t"/>
@@ -19261,7 +19215,6 @@
             <a:avLst/>
           </a:prstGeom>
           <a:noFill/>
-          <a:ln/>
         </p:spPr>
         <p:txBody>
           <a:bodyPr wrap="square" lIns="0" tIns="0" rIns="0" bIns="0" rtlCol="0" anchor="t"/>
@@ -19490,7 +19443,6 @@
             <a:avLst/>
           </a:prstGeom>
           <a:noFill/>
-          <a:ln/>
         </p:spPr>
         <p:txBody>
           <a:bodyPr wrap="square" lIns="0" tIns="0" rIns="0" bIns="0" rtlCol="0" anchor="t"/>
@@ -19527,7 +19479,6 @@
             <a:avLst/>
           </a:prstGeom>
           <a:noFill/>
-          <a:ln/>
         </p:spPr>
         <p:txBody>
           <a:bodyPr wrap="square" lIns="0" tIns="0" rIns="0" bIns="0" rtlCol="0" anchor="t"/>
@@ -19584,7 +19535,7 @@
       </p:grpSpPr>
       <p:sp>
         <p:nvSpPr>
-          <p:cNvPr id="11" name="hero"/>
+          <p:cNvPr id="11" name="r"/>
           <p:cNvSpPr/>
           <p:nvPr/>
         </p:nvSpPr>
@@ -19610,7 +19561,6 @@
             </a:gsLst>
             <a:lin ang="2700000" scaled="1"/>
           </a:gradFill>
-          <a:ln/>
         </p:spPr>
         <p:txBody>
           <a:bodyPr/>
@@ -19635,7 +19585,6 @@
             <a:avLst/>
           </a:prstGeom>
           <a:noFill/>
-          <a:ln/>
         </p:spPr>
         <p:txBody>
           <a:bodyPr wrap="square" lIns="0" tIns="0" rIns="0" bIns="0" rtlCol="0" anchor="t"/>
@@ -19672,7 +19621,6 @@
             <a:avLst/>
           </a:prstGeom>
           <a:noFill/>
-          <a:ln/>
         </p:spPr>
         <p:txBody>
           <a:bodyPr wrap="square" lIns="0" tIns="0" rIns="0" bIns="0" rtlCol="0" anchor="t"/>
@@ -19712,7 +19660,6 @@
             <a:avLst/>
           </a:prstGeom>
           <a:noFill/>
-          <a:ln/>
         </p:spPr>
         <p:txBody>
           <a:bodyPr wrap="square" lIns="0" tIns="0" rIns="0" bIns="0" rtlCol="0" anchor="t"/>
@@ -20003,7 +19950,7 @@
       </p:sp>
       <p:sp>
         <p:nvSpPr>
-          <p:cNvPr id="18" name="strip"/>
+          <p:cNvPr id="18" name="r"/>
           <p:cNvSpPr/>
           <p:nvPr/>
         </p:nvSpPr>
@@ -20018,7 +19965,6 @@
           <a:solidFill>
             <a:srgbClr val="0F6E56"/>
           </a:solidFill>
-          <a:ln/>
         </p:spPr>
         <p:txBody>
           <a:bodyPr/>
@@ -20043,7 +19989,6 @@
             <a:avLst/>
           </a:prstGeom>
           <a:noFill/>
-          <a:ln/>
         </p:spPr>
         <p:txBody>
           <a:bodyPr wrap="square" lIns="0" tIns="0" rIns="0" bIns="0" rtlCol="0" anchor="t"/>
@@ -20067,7 +20012,7 @@
       </p:sp>
       <p:sp>
         <p:nvSpPr>
-          <p:cNvPr id="20" name="strip"/>
+          <p:cNvPr id="20" name="r"/>
           <p:cNvSpPr/>
           <p:nvPr/>
         </p:nvSpPr>
@@ -20082,7 +20027,6 @@
           <a:solidFill>
             <a:srgbClr val="0F6E56"/>
           </a:solidFill>
-          <a:ln/>
         </p:spPr>
         <p:txBody>
           <a:bodyPr/>
@@ -20107,7 +20051,6 @@
             <a:avLst/>
           </a:prstGeom>
           <a:noFill/>
-          <a:ln/>
         </p:spPr>
         <p:txBody>
           <a:bodyPr wrap="square" lIns="0" tIns="0" rIns="0" bIns="0" rtlCol="0" anchor="t"/>
@@ -20144,7 +20087,6 @@
             <a:avLst/>
           </a:prstGeom>
           <a:noFill/>
-          <a:ln/>
         </p:spPr>
         <p:txBody>
           <a:bodyPr wrap="square" lIns="0" tIns="0" rIns="0" bIns="0" rtlCol="0" anchor="t"/>
@@ -20291,7 +20233,6 @@
             <a:avLst/>
           </a:prstGeom>
           <a:noFill/>
-          <a:ln/>
         </p:spPr>
         <p:txBody>
           <a:bodyPr wrap="square" lIns="0" tIns="0" rIns="0" bIns="0" rtlCol="0" anchor="t"/>
@@ -20478,7 +20419,6 @@
             <a:avLst/>
           </a:prstGeom>
           <a:noFill/>
-          <a:ln/>
         </p:spPr>
         <p:txBody>
           <a:bodyPr wrap="square" lIns="0" tIns="0" rIns="0" bIns="0" rtlCol="0" anchor="t"/>
@@ -20515,7 +20455,6 @@
             <a:avLst/>
           </a:prstGeom>
           <a:noFill/>
-          <a:ln/>
         </p:spPr>
         <p:txBody>
           <a:bodyPr wrap="square" lIns="0" tIns="0" rIns="0" bIns="0" rtlCol="0" anchor="t"/>
@@ -20552,7 +20491,6 @@
             <a:avLst/>
           </a:prstGeom>
           <a:noFill/>
-          <a:ln/>
         </p:spPr>
         <p:txBody>
           <a:bodyPr wrap="square" lIns="0" tIns="0" rIns="0" bIns="0" rtlCol="0" anchor="t"/>

</xml_diff>

<commit_message>
Fix unreadable pptx: resolve relationship ID collision
Root cause of the corruption: presentation.xml.rels already used
rId24-rId27 for presProps, viewProps, theme and tableStyles. The new
slides had been assigned rId24-rId28, duplicating those IDs and pointing
slide references at the wrong targets, which made the whole package
unreadable. Reassign the 5 new slides to rId28-rId32 (max existing 27).

Co-Authored-By: Claude Opus 4.8 <noreply@anthropic.com>
Claude-Session: https://claude.ai/code/session_016aCZqJCZT6xQTnHn6zqHR8
</commit_message>
<xml_diff>
--- a/AsiaGo_Pass_Presentation1_enhanced.pptx
+++ b/AsiaGo_Pass_Presentation1_enhanced.pptx
@@ -17,11 +17,11 @@
     <p:sldId id="269" r:id="rId8"/>
     <p:sldId id="278" r:id="rId9"/>
     <p:sldId id="274" r:id="rId10"/>
-    <p:sldId id="300" r:id="rId24"/>
-    <p:sldId id="301" r:id="rId25"/>
-    <p:sldId id="302" r:id="rId26"/>
-    <p:sldId id="303" r:id="rId27"/>
-    <p:sldId id="304" r:id="rId28"/>
+    <p:sldId id="300" r:id="rId28"/>
+    <p:sldId id="301" r:id="rId29"/>
+    <p:sldId id="302" r:id="rId30"/>
+    <p:sldId id="303" r:id="rId31"/>
+    <p:sldId id="304" r:id="rId32"/>
     <p:sldId id="275" r:id="rId11"/>
     <p:sldId id="258" r:id="rId12"/>
     <p:sldId id="273" r:id="rId13"/>

</xml_diff>